<commit_message>
Make it not seem broken that slides have missing benefits
</commit_message>
<xml_diff>
--- a/Slides/Module 01.2 User Stories.pptx
+++ b/Slides/Module 01.2 User Stories.pptx
@@ -271,7 +271,7 @@
           <a:p>
             <a:fld id="{7C7E5181-6CF5-45F7-A87A-E0E0B1FD7549}" type="datetimeFigureOut">
               <a:rPr lang="en-US" smtClean="0"/>
-              <a:t>1/7/2026</a:t>
+              <a:t>1/13/26</a:t>
             </a:fld>
             <a:endParaRPr lang="en-US"/>
           </a:p>
@@ -1776,6 +1776,32 @@
               <a:t>Q: What's the benefit here?</a:t>
             </a:r>
           </a:p>
+          <a:p>
+            <a:endParaRPr lang="en-US" dirty="0"/>
+          </a:p>
+          <a:p>
+            <a:r>
+              <a:rPr lang="en-US" dirty="0"/>
+              <a:t>(Possible answers: so that I know were to start, so that I understand where to drive next, so that I can view and report my progress, etc. The conditions of satisfaction currently listed on the next page are kind of tuned towards a “so that I can view and report my progress” benefit… though it would be reasonable for students to point out that calling “report my progress” as a </a:t>
+            </a:r>
+            <a:r>
+              <a:rPr lang="en-US" i="1" dirty="0"/>
+              <a:t>benefit </a:t>
+            </a:r>
+            <a:r>
+              <a:rPr lang="en-US" i="0" dirty="0"/>
+              <a:t>really is smuggling in an additional </a:t>
+            </a:r>
+            <a:r>
+              <a:rPr lang="en-US" i="1" dirty="0"/>
+              <a:t>capability</a:t>
+            </a:r>
+            <a:r>
+              <a:rPr lang="en-US" i="0" dirty="0"/>
+              <a:t>.)</a:t>
+            </a:r>
+            <a:endParaRPr lang="en-US" dirty="0"/>
+          </a:p>
         </p:txBody>
       </p:sp>
       <p:sp>
@@ -1860,13 +1886,112 @@
           <a:p>
             <a:r>
               <a:rPr lang="en-US" dirty="0"/>
+              <a:t>(Suggestion for future: revise the benefit so that it’s not smuggling in a new capability, and come up with new conditions of satisfaction better suited to that benefit.)</a:t>
+            </a:r>
+          </a:p>
+        </p:txBody>
+      </p:sp>
+      <p:sp>
+        <p:nvSpPr>
+          <p:cNvPr id="4" name="Slide Number Placeholder 3"/>
+          <p:cNvSpPr>
+            <a:spLocks noGrp="1"/>
+          </p:cNvSpPr>
+          <p:nvPr>
+            <p:ph type="sldNum" sz="quarter" idx="5"/>
+          </p:nvPr>
+        </p:nvSpPr>
+        <p:spPr/>
+        <p:txBody>
+          <a:bodyPr/>
+          <a:lstStyle/>
+          <a:p>
+            <a:fld id="{07937F07-1250-4CCE-B198-1B2887014F41}" type="slidenum">
+              <a:rPr lang="en-US" smtClean="0"/>
+              <a:t>20</a:t>
+            </a:fld>
+            <a:endParaRPr lang="en-US"/>
+          </a:p>
+        </p:txBody>
+      </p:sp>
+    </p:spTree>
+    <p:extLst>
+      <p:ext uri="{BB962C8B-B14F-4D97-AF65-F5344CB8AC3E}">
+        <p14:creationId xmlns:p14="http://schemas.microsoft.com/office/powerpoint/2010/main" val="117297898"/>
+      </p:ext>
+    </p:extLst>
+  </p:cSld>
+  <p:clrMapOvr>
+    <a:masterClrMapping/>
+  </p:clrMapOvr>
+</p:notes>
+</file>
+
+<file path=ppt/notesSlides/notesSlide19.xml><?xml version="1.0" encoding="utf-8"?>
+<p:notes xmlns:a="http://schemas.openxmlformats.org/drawingml/2006/main" xmlns:r="http://schemas.openxmlformats.org/officeDocument/2006/relationships" xmlns:p="http://schemas.openxmlformats.org/presentationml/2006/main">
+  <p:cSld>
+    <p:spTree>
+      <p:nvGrpSpPr>
+        <p:cNvPr id="1" name=""/>
+        <p:cNvGrpSpPr/>
+        <p:nvPr/>
+      </p:nvGrpSpPr>
+      <p:grpSpPr>
+        <a:xfrm>
+          <a:off x="0" y="0"/>
+          <a:ext cx="0" cy="0"/>
+          <a:chOff x="0" y="0"/>
+          <a:chExt cx="0" cy="0"/>
+        </a:xfrm>
+      </p:grpSpPr>
+      <p:sp>
+        <p:nvSpPr>
+          <p:cNvPr id="2" name="Slide Image Placeholder 1"/>
+          <p:cNvSpPr>
+            <a:spLocks noGrp="1" noRot="1" noChangeAspect="1"/>
+          </p:cNvSpPr>
+          <p:nvPr>
+            <p:ph type="sldImg"/>
+          </p:nvPr>
+        </p:nvSpPr>
+        <p:spPr/>
+      </p:sp>
+      <p:sp>
+        <p:nvSpPr>
+          <p:cNvPr id="3" name="Notes Placeholder 2"/>
+          <p:cNvSpPr>
+            <a:spLocks noGrp="1"/>
+          </p:cNvSpPr>
+          <p:nvPr>
+            <p:ph type="body" idx="1"/>
+          </p:nvPr>
+        </p:nvSpPr>
+        <p:spPr/>
+        <p:txBody>
+          <a:bodyPr/>
+          <a:lstStyle/>
+          <a:p>
+            <a:r>
+              <a:rPr lang="en-US" dirty="0"/>
               <a:t>Maybe this is desirable, maybe it's essential.</a:t>
             </a:r>
           </a:p>
           <a:p>
+            <a:endParaRPr lang="en-US" dirty="0"/>
+          </a:p>
+          <a:p>
             <a:r>
               <a:rPr lang="en-US" dirty="0"/>
               <a:t>Q: What's the benefit to the maintenance supervisor?</a:t>
+            </a:r>
+          </a:p>
+          <a:p>
+            <a:endParaRPr lang="en-US" dirty="0"/>
+          </a:p>
+          <a:p>
+            <a:r>
+              <a:rPr lang="en-US" dirty="0"/>
+              <a:t>(A: Obviously lots of answers — so that people are the most safe, so that the most dangerous potholes are prioritized, so that the mayor’s political donors receive preferential treatment, so that complaints to city hall about potholes are minimized.)</a:t>
             </a:r>
           </a:p>
         </p:txBody>
@@ -1967,118 +2092,6 @@
 </p:notes>
 </file>
 
-<file path=ppt/notesSlides/notesSlide19.xml><?xml version="1.0" encoding="utf-8"?>
-<p:notes xmlns:a="http://schemas.openxmlformats.org/drawingml/2006/main" xmlns:r="http://schemas.openxmlformats.org/officeDocument/2006/relationships" xmlns:p="http://schemas.openxmlformats.org/presentationml/2006/main">
-  <p:cSld>
-    <p:spTree>
-      <p:nvGrpSpPr>
-        <p:cNvPr id="1" name=""/>
-        <p:cNvGrpSpPr/>
-        <p:nvPr/>
-      </p:nvGrpSpPr>
-      <p:grpSpPr>
-        <a:xfrm>
-          <a:off x="0" y="0"/>
-          <a:ext cx="0" cy="0"/>
-          <a:chOff x="0" y="0"/>
-          <a:chExt cx="0" cy="0"/>
-        </a:xfrm>
-      </p:grpSpPr>
-      <p:sp>
-        <p:nvSpPr>
-          <p:cNvPr id="2" name="Slide Image Placeholder 1"/>
-          <p:cNvSpPr>
-            <a:spLocks noGrp="1" noRot="1" noChangeAspect="1"/>
-          </p:cNvSpPr>
-          <p:nvPr>
-            <p:ph type="sldImg"/>
-          </p:nvPr>
-        </p:nvSpPr>
-        <p:spPr/>
-      </p:sp>
-      <p:sp>
-        <p:nvSpPr>
-          <p:cNvPr id="3" name="Notes Placeholder 2"/>
-          <p:cNvSpPr>
-            <a:spLocks noGrp="1"/>
-          </p:cNvSpPr>
-          <p:nvPr>
-            <p:ph type="body" idx="1"/>
-          </p:nvPr>
-        </p:nvSpPr>
-        <p:spPr/>
-        <p:txBody>
-          <a:bodyPr/>
-          <a:lstStyle/>
-          <a:p>
-            <a:r>
-              <a:rPr lang="en-US" dirty="0"/>
-              <a:t>Discussion: do these </a:t>
-            </a:r>
-            <a:r>
-              <a:rPr lang="en-US" dirty="0" err="1"/>
-              <a:t>CoS</a:t>
-            </a:r>
-            <a:r>
-              <a:rPr lang="en-US" dirty="0"/>
-              <a:t> pertain to the supervisor's desire to /control/ the order in which the potholes are repaired?   </a:t>
-            </a:r>
-          </a:p>
-          <a:p>
-            <a:endParaRPr lang="en-US" dirty="0"/>
-          </a:p>
-          <a:p>
-            <a:r>
-              <a:rPr lang="en-US" dirty="0"/>
-              <a:t>Prof. Wand says: these COS are about "planning" the order in which the potholes should be repaired, but it doesn't give him any _control_. If he wants to **control** the order, shouldn't there be a </a:t>
-            </a:r>
-            <a:r>
-              <a:rPr lang="en-US" dirty="0" err="1"/>
-              <a:t>CoS</a:t>
-            </a:r>
-            <a:r>
-              <a:rPr lang="en-US" dirty="0"/>
-              <a:t> something like "I should be able to assign each repair crew an individual set of potholes, and communicate this assignment to the crew"?? </a:t>
-            </a:r>
-          </a:p>
-        </p:txBody>
-      </p:sp>
-      <p:sp>
-        <p:nvSpPr>
-          <p:cNvPr id="4" name="Slide Number Placeholder 3"/>
-          <p:cNvSpPr>
-            <a:spLocks noGrp="1"/>
-          </p:cNvSpPr>
-          <p:nvPr>
-            <p:ph type="sldNum" sz="quarter" idx="5"/>
-          </p:nvPr>
-        </p:nvSpPr>
-        <p:spPr/>
-        <p:txBody>
-          <a:bodyPr/>
-          <a:lstStyle/>
-          <a:p>
-            <a:fld id="{07937F07-1250-4CCE-B198-1B2887014F41}" type="slidenum">
-              <a:rPr lang="en-US" smtClean="0"/>
-              <a:t>22</a:t>
-            </a:fld>
-            <a:endParaRPr lang="en-US"/>
-          </a:p>
-        </p:txBody>
-      </p:sp>
-    </p:spTree>
-    <p:extLst>
-      <p:ext uri="{BB962C8B-B14F-4D97-AF65-F5344CB8AC3E}">
-        <p14:creationId xmlns:p14="http://schemas.microsoft.com/office/powerpoint/2010/main" val="3525442661"/>
-      </p:ext>
-    </p:extLst>
-  </p:cSld>
-  <p:clrMapOvr>
-    <a:masterClrMapping/>
-  </p:clrMapOvr>
-</p:notes>
-</file>
-
 <file path=ppt/notesSlides/notesSlide2.xml><?xml version="1.0" encoding="utf-8"?>
 <p:notes xmlns:a="http://schemas.openxmlformats.org/drawingml/2006/main" xmlns:r="http://schemas.openxmlformats.org/officeDocument/2006/relationships" xmlns:p="http://schemas.openxmlformats.org/presentationml/2006/main">
   <p:cSld>
@@ -2209,7 +2222,15 @@
           <a:p>
             <a:r>
               <a:rPr lang="en-US" dirty="0"/>
-              <a:t>INVEST is a popular mnemonic for describing what makes a good user story  (INVEST is widely used-- we've added the E because we think it's important)</a:t>
+              <a:t>Discussion: do these </a:t>
+            </a:r>
+            <a:r>
+              <a:rPr lang="en-US" dirty="0" err="1"/>
+              <a:t>CoS</a:t>
+            </a:r>
+            <a:r>
+              <a:rPr lang="en-US" dirty="0"/>
+              <a:t> pertain to the supervisor's desire to /control/ the order in which the potholes are repaired?   </a:t>
             </a:r>
           </a:p>
           <a:p>
@@ -2218,16 +2239,15 @@
           <a:p>
             <a:r>
               <a:rPr lang="en-US" dirty="0"/>
-              <a:t>Independent – Stories should not be coupled between each other, except where obviously necessary. Want to make it so that a user can examine a story on its own</a:t>
-            </a:r>
-          </a:p>
-          <a:p>
-            <a:br>
-              <a:rPr lang="en-US" dirty="0"/>
-            </a:br>
-            <a:r>
-              <a:rPr lang="en-US" dirty="0"/>
-              <a:t>Negotiable – Best stories are result of a negotiation between a client and a developer – how do we come to some mutual agreement about what we are going to build, and why? Goal is to develop what the customer needs</a:t>
+              <a:t>Prof. Wand says: these COS are about "planning" the order in which the potholes should be repaired, but it doesn't give him any _control_. If he wants to **control** the order, shouldn't there be a </a:t>
+            </a:r>
+            <a:r>
+              <a:rPr lang="en-US" dirty="0" err="1"/>
+              <a:t>CoS</a:t>
+            </a:r>
+            <a:r>
+              <a:rPr lang="en-US" dirty="0"/>
+              <a:t> something like "I should be able to assign each repair crew an individual set of potholes, and communicate this assignment to the crew"?? </a:t>
             </a:r>
           </a:p>
           <a:p>
@@ -2236,112 +2256,13 @@
           <a:p>
             <a:r>
               <a:rPr lang="en-US" dirty="0"/>
-              <a:t>Valuable – Each story should have some benefit that the client can recognize. Value might include value to your business, not just value to the user.</a:t>
-            </a:r>
-          </a:p>
-          <a:p>
+              <a:t>(Suggestion for future: revise benefit and/or conditions of satisfaction. Though it’s potentially good for in-class conversation that these are </a:t>
+            </a:r>
+            <a:r>
+              <a:rPr lang="en-US"/>
+              <a:t>a little bit wonky!)</a:t>
+            </a:r>
             <a:endParaRPr lang="en-US" dirty="0"/>
-          </a:p>
-          <a:p>
-            <a:r>
-              <a:rPr lang="en-US" dirty="0"/>
-              <a:t>Estimable (that is, </a:t>
-            </a:r>
-            <a:r>
-              <a:rPr lang="en-US" dirty="0" err="1"/>
-              <a:t>estimatable</a:t>
-            </a:r>
-            <a:r>
-              <a:rPr lang="en-US" dirty="0"/>
-              <a:t>) – As we will see in a bit, being able to estimate how long it will take to implement a user story is key to determining a reasonable scope for your project</a:t>
-            </a:r>
-          </a:p>
-          <a:p>
-            <a:endParaRPr lang="en-US" dirty="0"/>
-          </a:p>
-          <a:p>
-            <a:r>
-              <a:rPr lang="en-US" dirty="0"/>
-              <a:t>Small – In  the real world, a rule of thumb is to average 3-4 days of work per story for a full-time developer.  For our projects, it might be something a single student might be able to accomplish in a week, along with their other obligations as a student.</a:t>
-            </a:r>
-          </a:p>
-          <a:p>
-            <a:endParaRPr lang="en-US" dirty="0"/>
-          </a:p>
-          <a:p>
-            <a:r>
-              <a:rPr lang="en-US" dirty="0"/>
-              <a:t>Testable – There must be some way to judge completion: for the person implementing the software, and for the end-user. </a:t>
-            </a:r>
-          </a:p>
-          <a:p>
-            <a:endParaRPr lang="en-US" dirty="0"/>
-          </a:p>
-          <a:p>
-            <a:r>
-              <a:rPr lang="en-US" dirty="0"/>
-              <a:t>These </a:t>
-            </a:r>
-            <a:r>
-              <a:rPr lang="en-US" dirty="0" err="1"/>
-              <a:t>critera</a:t>
-            </a:r>
-            <a:r>
-              <a:rPr lang="en-US" dirty="0"/>
-              <a:t> tell you whether a user story is good at the </a:t>
-            </a:r>
-            <a:r>
-              <a:rPr lang="en-US" i="1" dirty="0"/>
-              <a:t>organizational level — </a:t>
-            </a:r>
-            <a:r>
-              <a:rPr lang="en-US" i="0" dirty="0"/>
-              <a:t>whether it’s useful to organize a software project. “Good” here doesn’t mean that the user story is worth doing, or ethical</a:t>
-            </a:r>
-            <a:endParaRPr lang="en-US" dirty="0"/>
-          </a:p>
-          <a:p>
-            <a:r>
-              <a:rPr lang="en-US" dirty="0"/>
-              <a:t>https://</a:t>
-            </a:r>
-            <a:r>
-              <a:rPr lang="en-US" dirty="0" err="1"/>
-              <a:t>agileforall.com</a:t>
-            </a:r>
-            <a:r>
-              <a:rPr lang="en-US" dirty="0"/>
-              <a:t>/new-to-agile-invest-in-good-user-stories/</a:t>
-            </a:r>
-          </a:p>
-          <a:p>
-            <a:endParaRPr lang="en-US" dirty="0"/>
-          </a:p>
-          <a:p>
-            <a:endParaRPr lang="en-US" dirty="0"/>
-          </a:p>
-          <a:p>
-            <a:pPr marL="0" marR="0" lvl="0" indent="0" algn="l" defTabSz="914400" rtl="0" eaLnBrk="1" fontAlgn="auto" latinLnBrk="0" hangingPunct="1">
-              <a:lnSpc>
-                <a:spcPct val="100000"/>
-              </a:lnSpc>
-              <a:spcBef>
-                <a:spcPts val="0"/>
-              </a:spcBef>
-              <a:spcAft>
-                <a:spcPts val="0"/>
-              </a:spcAft>
-              <a:buClrTx/>
-              <a:buSzTx/>
-              <a:buFontTx/>
-              <a:buNone/>
-              <a:tabLst/>
-              <a:defRPr/>
-            </a:pPr>
-            <a:r>
-              <a:rPr lang="en-US" dirty="0"/>
-              <a:t>… Let’s see an example and work through some of the tricky bits</a:t>
-            </a:r>
           </a:p>
         </p:txBody>
       </p:sp>
@@ -2362,7 +2283,7 @@
           <a:p>
             <a:fld id="{07937F07-1250-4CCE-B198-1B2887014F41}" type="slidenum">
               <a:rPr lang="en-US" smtClean="0"/>
-              <a:t>23</a:t>
+              <a:t>22</a:t>
             </a:fld>
             <a:endParaRPr lang="en-US"/>
           </a:p>
@@ -2371,7 +2292,7 @@
     </p:spTree>
     <p:extLst>
       <p:ext uri="{BB962C8B-B14F-4D97-AF65-F5344CB8AC3E}">
-        <p14:creationId xmlns:p14="http://schemas.microsoft.com/office/powerpoint/2010/main" val="1695675977"/>
+        <p14:creationId xmlns:p14="http://schemas.microsoft.com/office/powerpoint/2010/main" val="3525442661"/>
       </p:ext>
     </p:extLst>
   </p:cSld>
@@ -2425,6 +2346,224 @@
           <a:bodyPr/>
           <a:lstStyle/>
           <a:p>
+            <a:r>
+              <a:rPr lang="en-US" dirty="0"/>
+              <a:t>INVEST is a popular mnemonic for describing what makes a good user story  (INVEST is widely used-- we've added the E because we think it's important)</a:t>
+            </a:r>
+          </a:p>
+          <a:p>
+            <a:endParaRPr lang="en-US" dirty="0"/>
+          </a:p>
+          <a:p>
+            <a:r>
+              <a:rPr lang="en-US" dirty="0"/>
+              <a:t>Independent – Stories should not be coupled between each other, except where obviously necessary. Want to make it so that a user can examine a story on its own</a:t>
+            </a:r>
+          </a:p>
+          <a:p>
+            <a:br>
+              <a:rPr lang="en-US" dirty="0"/>
+            </a:br>
+            <a:r>
+              <a:rPr lang="en-US" dirty="0"/>
+              <a:t>Negotiable – Best stories are result of a negotiation between a client and a developer – how do we come to some mutual agreement about what we are going to build, and why? Goal is to develop what the customer needs</a:t>
+            </a:r>
+          </a:p>
+          <a:p>
+            <a:endParaRPr lang="en-US" dirty="0"/>
+          </a:p>
+          <a:p>
+            <a:r>
+              <a:rPr lang="en-US" dirty="0"/>
+              <a:t>Valuable – Each story should have some benefit that the client can recognize. Value might include value to your business, not just value to the user.</a:t>
+            </a:r>
+          </a:p>
+          <a:p>
+            <a:endParaRPr lang="en-US" dirty="0"/>
+          </a:p>
+          <a:p>
+            <a:r>
+              <a:rPr lang="en-US" dirty="0"/>
+              <a:t>Estimable (that is, </a:t>
+            </a:r>
+            <a:r>
+              <a:rPr lang="en-US" dirty="0" err="1"/>
+              <a:t>estimatable</a:t>
+            </a:r>
+            <a:r>
+              <a:rPr lang="en-US" dirty="0"/>
+              <a:t>) – As we will see in a bit, being able to estimate how long it will take to implement a user story is key to determining a reasonable scope for your project</a:t>
+            </a:r>
+          </a:p>
+          <a:p>
+            <a:endParaRPr lang="en-US" dirty="0"/>
+          </a:p>
+          <a:p>
+            <a:r>
+              <a:rPr lang="en-US" dirty="0"/>
+              <a:t>Small – In  the real world, a rule of thumb is to average 3-4 days of work per story for a full-time developer.  For our projects, it might be something a single student might be able to accomplish in a week, along with their other obligations as a student.</a:t>
+            </a:r>
+          </a:p>
+          <a:p>
+            <a:endParaRPr lang="en-US" dirty="0"/>
+          </a:p>
+          <a:p>
+            <a:r>
+              <a:rPr lang="en-US" dirty="0"/>
+              <a:t>Testable – There must be some way to judge completion: for the person implementing the software, and for the end-user. </a:t>
+            </a:r>
+          </a:p>
+          <a:p>
+            <a:endParaRPr lang="en-US" dirty="0"/>
+          </a:p>
+          <a:p>
+            <a:r>
+              <a:rPr lang="en-US" dirty="0"/>
+              <a:t>These </a:t>
+            </a:r>
+            <a:r>
+              <a:rPr lang="en-US" dirty="0" err="1"/>
+              <a:t>critera</a:t>
+            </a:r>
+            <a:r>
+              <a:rPr lang="en-US" dirty="0"/>
+              <a:t> tell you whether a user story is good at the </a:t>
+            </a:r>
+            <a:r>
+              <a:rPr lang="en-US" i="1" dirty="0"/>
+              <a:t>organizational level — </a:t>
+            </a:r>
+            <a:r>
+              <a:rPr lang="en-US" i="0" dirty="0"/>
+              <a:t>whether it’s useful to organize a software project. “Good” here doesn’t mean that the user story is worth doing, or ethical</a:t>
+            </a:r>
+            <a:endParaRPr lang="en-US" dirty="0"/>
+          </a:p>
+          <a:p>
+            <a:r>
+              <a:rPr lang="en-US" dirty="0"/>
+              <a:t>https://</a:t>
+            </a:r>
+            <a:r>
+              <a:rPr lang="en-US" dirty="0" err="1"/>
+              <a:t>agileforall.com</a:t>
+            </a:r>
+            <a:r>
+              <a:rPr lang="en-US" dirty="0"/>
+              <a:t>/new-to-agile-invest-in-good-user-stories/</a:t>
+            </a:r>
+          </a:p>
+          <a:p>
+            <a:endParaRPr lang="en-US" dirty="0"/>
+          </a:p>
+          <a:p>
+            <a:endParaRPr lang="en-US" dirty="0"/>
+          </a:p>
+          <a:p>
+            <a:pPr marL="0" marR="0" lvl="0" indent="0" algn="l" defTabSz="914400" rtl="0" eaLnBrk="1" fontAlgn="auto" latinLnBrk="0" hangingPunct="1">
+              <a:lnSpc>
+                <a:spcPct val="100000"/>
+              </a:lnSpc>
+              <a:spcBef>
+                <a:spcPts val="0"/>
+              </a:spcBef>
+              <a:spcAft>
+                <a:spcPts val="0"/>
+              </a:spcAft>
+              <a:buClrTx/>
+              <a:buSzTx/>
+              <a:buFontTx/>
+              <a:buNone/>
+              <a:tabLst/>
+              <a:defRPr/>
+            </a:pPr>
+            <a:r>
+              <a:rPr lang="en-US" dirty="0"/>
+              <a:t>… Let’s see an example and work through some of the tricky bits</a:t>
+            </a:r>
+          </a:p>
+        </p:txBody>
+      </p:sp>
+      <p:sp>
+        <p:nvSpPr>
+          <p:cNvPr id="4" name="Slide Number Placeholder 3"/>
+          <p:cNvSpPr>
+            <a:spLocks noGrp="1"/>
+          </p:cNvSpPr>
+          <p:nvPr>
+            <p:ph type="sldNum" sz="quarter" idx="5"/>
+          </p:nvPr>
+        </p:nvSpPr>
+        <p:spPr/>
+        <p:txBody>
+          <a:bodyPr/>
+          <a:lstStyle/>
+          <a:p>
+            <a:fld id="{07937F07-1250-4CCE-B198-1B2887014F41}" type="slidenum">
+              <a:rPr lang="en-US" smtClean="0"/>
+              <a:t>23</a:t>
+            </a:fld>
+            <a:endParaRPr lang="en-US"/>
+          </a:p>
+        </p:txBody>
+      </p:sp>
+    </p:spTree>
+    <p:extLst>
+      <p:ext uri="{BB962C8B-B14F-4D97-AF65-F5344CB8AC3E}">
+        <p14:creationId xmlns:p14="http://schemas.microsoft.com/office/powerpoint/2010/main" val="1695675977"/>
+      </p:ext>
+    </p:extLst>
+  </p:cSld>
+  <p:clrMapOvr>
+    <a:masterClrMapping/>
+  </p:clrMapOvr>
+</p:notes>
+</file>
+
+<file path=ppt/notesSlides/notesSlide22.xml><?xml version="1.0" encoding="utf-8"?>
+<p:notes xmlns:a="http://schemas.openxmlformats.org/drawingml/2006/main" xmlns:r="http://schemas.openxmlformats.org/officeDocument/2006/relationships" xmlns:p="http://schemas.openxmlformats.org/presentationml/2006/main">
+  <p:cSld>
+    <p:spTree>
+      <p:nvGrpSpPr>
+        <p:cNvPr id="1" name=""/>
+        <p:cNvGrpSpPr/>
+        <p:nvPr/>
+      </p:nvGrpSpPr>
+      <p:grpSpPr>
+        <a:xfrm>
+          <a:off x="0" y="0"/>
+          <a:ext cx="0" cy="0"/>
+          <a:chOff x="0" y="0"/>
+          <a:chExt cx="0" cy="0"/>
+        </a:xfrm>
+      </p:grpSpPr>
+      <p:sp>
+        <p:nvSpPr>
+          <p:cNvPr id="2" name="Slide Image Placeholder 1"/>
+          <p:cNvSpPr>
+            <a:spLocks noGrp="1" noRot="1" noChangeAspect="1"/>
+          </p:cNvSpPr>
+          <p:nvPr>
+            <p:ph type="sldImg"/>
+          </p:nvPr>
+        </p:nvSpPr>
+        <p:spPr/>
+      </p:sp>
+      <p:sp>
+        <p:nvSpPr>
+          <p:cNvPr id="3" name="Notes Placeholder 2"/>
+          <p:cNvSpPr>
+            <a:spLocks noGrp="1"/>
+          </p:cNvSpPr>
+          <p:nvPr>
+            <p:ph type="body" idx="1"/>
+          </p:nvPr>
+        </p:nvSpPr>
+        <p:spPr/>
+        <p:txBody>
+          <a:bodyPr/>
+          <a:lstStyle/>
+          <a:p>
             <a:pPr marL="0" marR="0" lvl="0" indent="0" algn="l" defTabSz="914400" rtl="0" eaLnBrk="1" fontAlgn="auto" latinLnBrk="0" hangingPunct="1">
               <a:lnSpc>
                 <a:spcPct val="100000"/>
@@ -2683,7 +2822,7 @@
 </p:notes>
 </file>
 
-<file path=ppt/notesSlides/notesSlide22.xml><?xml version="1.0" encoding="utf-8"?>
+<file path=ppt/notesSlides/notesSlide23.xml><?xml version="1.0" encoding="utf-8"?>
 <p:notes xmlns:a="http://schemas.openxmlformats.org/drawingml/2006/main" xmlns:r="http://schemas.openxmlformats.org/officeDocument/2006/relationships" xmlns:p="http://schemas.openxmlformats.org/presentationml/2006/main">
   <p:cSld>
     <p:spTree>
@@ -2910,7 +3049,7 @@
 </p:notes>
 </file>
 
-<file path=ppt/notesSlides/notesSlide23.xml><?xml version="1.0" encoding="utf-8"?>
+<file path=ppt/notesSlides/notesSlide24.xml><?xml version="1.0" encoding="utf-8"?>
 <p:notes xmlns:a="http://schemas.openxmlformats.org/drawingml/2006/main" xmlns:r="http://schemas.openxmlformats.org/officeDocument/2006/relationships" xmlns:p="http://schemas.openxmlformats.org/presentationml/2006/main">
   <p:cSld>
     <p:spTree>
@@ -3049,7 +3188,7 @@
 </p:notes>
 </file>
 
-<file path=ppt/notesSlides/notesSlide24.xml><?xml version="1.0" encoding="utf-8"?>
+<file path=ppt/notesSlides/notesSlide25.xml><?xml version="1.0" encoding="utf-8"?>
 <p:notes xmlns:a="http://schemas.openxmlformats.org/drawingml/2006/main" xmlns:r="http://schemas.openxmlformats.org/officeDocument/2006/relationships" xmlns:p="http://schemas.openxmlformats.org/presentationml/2006/main">
   <p:cSld>
     <p:spTree>
@@ -4625,7 +4764,7 @@
           <a:p>
             <a:fld id="{5D2A64DE-480B-420F-9649-4F8E696E08E0}" type="datetime1">
               <a:rPr lang="en-US" smtClean="0"/>
-              <a:t>1/7/2026</a:t>
+              <a:t>1/13/26</a:t>
             </a:fld>
             <a:endParaRPr lang="en-US"/>
           </a:p>
@@ -4949,7 +5088,7 @@
           <a:p>
             <a:fld id="{EA476A42-A091-4468-A075-64A31BE59948}" type="datetime1">
               <a:rPr lang="en-US" smtClean="0"/>
-              <a:t>1/7/2026</a:t>
+              <a:t>1/13/26</a:t>
             </a:fld>
             <a:endParaRPr lang="en-US"/>
           </a:p>
@@ -5147,7 +5286,7 @@
           <a:p>
             <a:fld id="{0D3616D0-8311-4107-9726-6B805E7D05BA}" type="datetime1">
               <a:rPr lang="en-US" smtClean="0"/>
-              <a:t>1/7/2026</a:t>
+              <a:t>1/13/26</a:t>
             </a:fld>
             <a:endParaRPr lang="en-US"/>
           </a:p>
@@ -5355,7 +5494,7 @@
           <a:p>
             <a:fld id="{3BC2557A-5C88-417A-A763-5AC779462A5F}" type="datetime1">
               <a:rPr lang="en-US" smtClean="0"/>
-              <a:t>1/7/2026</a:t>
+              <a:t>1/13/26</a:t>
             </a:fld>
             <a:endParaRPr lang="en-US"/>
           </a:p>
@@ -5879,7 +6018,7 @@
           <a:p>
             <a:fld id="{07C7BFD4-467E-4EDE-93EA-052F5B39A4E5}" type="datetime1">
               <a:rPr lang="en-US" smtClean="0"/>
-              <a:t>1/7/2026</a:t>
+              <a:t>1/13/26</a:t>
             </a:fld>
             <a:endParaRPr lang="en-US"/>
           </a:p>
@@ -6129,7 +6268,7 @@
           <a:p>
             <a:fld id="{07C7BFD4-467E-4EDE-93EA-052F5B39A4E5}" type="datetime1">
               <a:rPr lang="en-US" smtClean="0"/>
-              <a:t>1/7/2026</a:t>
+              <a:t>1/13/26</a:t>
             </a:fld>
             <a:endParaRPr lang="en-US"/>
           </a:p>
@@ -6311,7 +6450,7 @@
           <a:p>
             <a:fld id="{109E55A0-C911-4F03-82FC-7E5926047D46}" type="datetime1">
               <a:rPr lang="en-US" smtClean="0"/>
-              <a:t>1/7/2026</a:t>
+              <a:t>1/13/26</a:t>
             </a:fld>
             <a:endParaRPr lang="en-US"/>
           </a:p>
@@ -6624,7 +6763,7 @@
           <a:p>
             <a:fld id="{A533CBE2-D5BE-47AC-ADC2-9CDFC1D0CF90}" type="datetime1">
               <a:rPr lang="en-US" smtClean="0"/>
-              <a:t>1/7/2026</a:t>
+              <a:t>1/13/26</a:t>
             </a:fld>
             <a:endParaRPr lang="en-US"/>
           </a:p>
@@ -6925,7 +7064,7 @@
           <a:p>
             <a:fld id="{39B7EDB1-CE74-4951-85A2-0B01C2128E28}" type="datetime1">
               <a:rPr lang="en-US" smtClean="0"/>
-              <a:t>1/7/2026</a:t>
+              <a:t>1/13/26</a:t>
             </a:fld>
             <a:endParaRPr lang="en-US"/>
           </a:p>
@@ -7373,7 +7512,7 @@
           <a:p>
             <a:fld id="{2BC7EB92-A5C2-4807-A9DC-9EDE6CBFB241}" type="datetime1">
               <a:rPr lang="en-US" smtClean="0"/>
-              <a:t>1/7/2026</a:t>
+              <a:t>1/13/26</a:t>
             </a:fld>
             <a:endParaRPr lang="en-US"/>
           </a:p>
@@ -7486,7 +7625,7 @@
           <a:p>
             <a:fld id="{2B7B7EE0-7771-4CD5-9B2B-3550753A54A1}" type="datetime1">
               <a:rPr lang="en-US" smtClean="0"/>
-              <a:t>1/7/2026</a:t>
+              <a:t>1/13/26</a:t>
             </a:fld>
             <a:endParaRPr lang="en-US"/>
           </a:p>
@@ -7797,7 +7936,7 @@
           <a:p>
             <a:fld id="{F8B318B3-0E87-4416-A9B8-D891968C2727}" type="datetime1">
               <a:rPr lang="en-US" smtClean="0"/>
-              <a:t>1/7/2026</a:t>
+              <a:t>1/13/26</a:t>
             </a:fld>
             <a:endParaRPr lang="en-US"/>
           </a:p>
@@ -8038,7 +8177,7 @@
           <a:p>
             <a:fld id="{54D997E8-DDEE-43F1-8D9B-F8A1E11DE488}" type="datetime1">
               <a:rPr lang="en-US" smtClean="0"/>
-              <a:t>1/7/2026</a:t>
+              <a:t>1/13/26</a:t>
             </a:fld>
             <a:endParaRPr lang="en-US"/>
           </a:p>
@@ -10766,7 +10905,7 @@
           <a:p>
             <a:r>
               <a:rPr lang="en-US" dirty="0"/>
-              <a:t>As a pothole-repair-truck driver, I want the system to display the potholes I should be working on today.</a:t>
+              <a:t>As a pothole-repair-truck driver, I want the system to display the potholes I should be working on today, so that… (?)</a:t>
             </a:r>
           </a:p>
         </p:txBody>
@@ -11118,7 +11257,7 @@
           <a:p>
             <a:r>
               <a:rPr lang="en-US" dirty="0"/>
-              <a:t>As a pothole-repair-truck driver, I want the system to display the potholes I should be working on today.</a:t>
+              <a:t>As a pothole-repair-truck driver, I want the system to display the potholes I should be working on today, so that I can view and report my progress through the day.</a:t>
             </a:r>
           </a:p>
           <a:p>
@@ -11343,7 +11482,7 @@
           <a:p>
             <a:r>
               <a:rPr lang="en-US" dirty="0"/>
-              <a:t>As a maintenance supervisor, I want to be able to control the order in which potholes are repaired</a:t>
+              <a:t>As a maintenance supervisor, I want to be able to control the order in which potholes are repaired, so that… (?)</a:t>
             </a:r>
           </a:p>
           <a:p>
@@ -11534,7 +11673,7 @@
         <p:spPr>
           <a:xfrm>
             <a:off x="838199" y="1500160"/>
-            <a:ext cx="9993923" cy="4351338"/>
+            <a:ext cx="9993923" cy="4856190"/>
           </a:xfrm>
         </p:spPr>
         <p:txBody>
@@ -11545,7 +11684,7 @@
           <a:p>
             <a:r>
               <a:rPr lang="en-US" dirty="0"/>
-              <a:t>As a maintenance supervisor, I want to be able to control the order in which potholes are repaired</a:t>
+              <a:t>As a maintenance supervisor, I want to be able to control the order in which potholes are repaired, so that complaints to city hall are minimized.</a:t>
             </a:r>
           </a:p>
           <a:p>

</xml_diff>